<commit_message>
Add Dockerfile instruction slides
</commit_message>
<xml_diff>
--- a/slides/docker-session4-dockerfile-resources.pptx
+++ b/slides/docker-session4-dockerfile-resources.pptx
@@ -10,7 +10,9 @@
     <p:sldId xmlns:r="http://schemas.openxmlformats.org/officeDocument/2006/relationships" id="258" r:id="R2cbc7cb8ee394c74"/>
     <p:sldId xmlns:r="http://schemas.openxmlformats.org/officeDocument/2006/relationships" id="259" r:id="Rb639ff8e4e31446a"/>
     <p:sldId xmlns:r="http://schemas.openxmlformats.org/officeDocument/2006/relationships" id="260" r:id="R03a227b220914ba2"/>
+    <p:sldId id="303" r:id="rIdCodexDockerfileMap48"/>
     <p:sldId id="288" r:id="rId1"/>
+    <p:sldId id="304" r:id="rIdCodexDockerfileBehavior49"/>
     <p:sldId xmlns:r="http://schemas.openxmlformats.org/officeDocument/2006/relationships" id="261" r:id="R81e94a9dc4f2475c"/>
     <p:sldId xmlns:r="http://schemas.openxmlformats.org/officeDocument/2006/relationships" id="262" r:id="R5b484a6d39784ca5"/>
     <p:sldId xmlns:r="http://schemas.openxmlformats.org/officeDocument/2006/relationships" id="263" r:id="Rf5f9986d0ea64937"/>
@@ -35633,6 +35635,2049 @@
 </p:sld>
 </file>
 
+<file path=ppt/slides/slide48.xml><?xml version="1.0" encoding="utf-8"?>
+<p:sld xmlns:a="http://schemas.openxmlformats.org/drawingml/2006/main" xmlns:p="http://schemas.openxmlformats.org/presentationml/2006/main" xmlns:r="http://schemas.openxmlformats.org/officeDocument/2006/relationships">
+  <p:cSld name="Dockerfile 常見指令地圖">
+    <p:bg>
+      <p:bgPr>
+        <a:solidFill>
+          <a:srgbClr val="F6F8FB"/>
+        </a:solidFill>
+      </p:bgPr>
+    </p:bg>
+    <p:spTree>
+      <p:nvGrpSpPr>
+        <p:cNvPr id="1" name=""/>
+        <p:cNvGrpSpPr/>
+        <p:nvPr/>
+      </p:nvGrpSpPr>
+      <p:grpSpPr>
+        <a:xfrm/>
+      </p:grpSpPr>
+      <p:sp>
+        <p:nvSpPr>
+          <p:cNvPr id="2" name=""/>
+          <p:cNvSpPr>
+            <a:spLocks noGrp="1"/>
+          </p:cNvSpPr>
+          <p:nvPr/>
+        </p:nvSpPr>
+        <p:spPr>
+          <a:xfrm>
+            <a:off x="609600" y="400050"/>
+            <a:ext cx="6191250" cy="228600"/>
+          </a:xfrm>
+          <a:prstGeom prst="rect">
+            <a:avLst/>
+          </a:prstGeom>
+          <a:noFill/>
+          <a:ln w="0">
+            <a:noFill/>
+            <a:prstDash val="solid"/>
+          </a:ln>
+        </p:spPr>
+        <p:txBody>
+          <a:bodyPr lIns="0" tIns="0" rIns="0" bIns="0" anchor="t">
+            <a:normAutofit fontScale="100000"/>
+          </a:bodyPr>
+          <a:lstStyle/>
+          <a:p>
+            <a:pPr algn="l">
+              <a:lnSpc>
+                <a:spcPct val="106000"/>
+              </a:lnSpc>
+              <a:buNone/>
+              <a:defRPr sz="900" b="1">
+                <a:solidFill>
+                  <a:srgbClr val="0B5CAD"/>
+                </a:solidFill>
+                <a:latin typeface="Aptos"/>
+                <a:ea typeface="Aptos"/>
+                <a:cs typeface="Aptos"/>
+              </a:defRPr>
+            </a:pPr>
+            <a:r>
+              <a:rPr sz="900" b="1">
+                <a:solidFill>
+                  <a:srgbClr val="0B5CAD"/>
+                </a:solidFill>
+                <a:latin typeface="Aptos"/>
+                <a:ea typeface="Aptos"/>
+                <a:cs typeface="Aptos"/>
+              </a:rPr>
+              <a:t>DOCKERFILE MAP</a:t>
+            </a:r>
+          </a:p>
+        </p:txBody>
+      </p:sp>
+      <p:sp>
+        <p:nvSpPr>
+          <p:cNvPr id="3" name=""/>
+          <p:cNvSpPr>
+            <a:spLocks noGrp="1"/>
+          </p:cNvSpPr>
+          <p:nvPr/>
+        </p:nvSpPr>
+        <p:spPr>
+          <a:xfrm>
+            <a:off x="609600" y="742950"/>
+            <a:ext cx="9906000" cy="571500"/>
+          </a:xfrm>
+          <a:prstGeom prst="rect">
+            <a:avLst/>
+          </a:prstGeom>
+          <a:noFill/>
+          <a:ln w="0">
+            <a:noFill/>
+            <a:prstDash val="solid"/>
+          </a:ln>
+        </p:spPr>
+        <p:txBody>
+          <a:bodyPr lIns="0" tIns="0" rIns="0" bIns="0" anchor="t">
+            <a:normAutofit fontScale="100000"/>
+          </a:bodyPr>
+          <a:lstStyle/>
+          <a:p>
+            <a:pPr algn="l">
+              <a:lnSpc>
+                <a:spcPct val="106000"/>
+              </a:lnSpc>
+              <a:buNone/>
+              <a:defRPr sz="2850" b="1">
+                <a:solidFill>
+                  <a:srgbClr val="0B1220"/>
+                </a:solidFill>
+                <a:latin typeface="Aptos Display"/>
+                <a:ea typeface="Aptos Display"/>
+                <a:cs typeface="Aptos Display"/>
+              </a:defRPr>
+            </a:pPr>
+            <a:r>
+              <a:rPr sz="2850" b="1">
+                <a:solidFill>
+                  <a:srgbClr val="0B1220"/>
+                </a:solidFill>
+                <a:latin typeface="Aptos Display"/>
+                <a:ea typeface="Aptos Display"/>
+                <a:cs typeface="Aptos Display"/>
+              </a:rPr>
+              <a:t>Dockerfile 常見指令地圖</a:t>
+            </a:r>
+          </a:p>
+        </p:txBody>
+      </p:sp>
+      <p:sp>
+        <p:nvSpPr>
+          <p:cNvPr id="4" name=""/>
+          <p:cNvSpPr>
+            <a:spLocks noGrp="1"/>
+          </p:cNvSpPr>
+          <p:nvPr/>
+        </p:nvSpPr>
+        <p:spPr>
+          <a:xfrm>
+            <a:off x="609600" y="1514475"/>
+            <a:ext cx="2571750" cy="971550"/>
+          </a:xfrm>
+          <a:prstGeom prst="roundRect">
+            <a:avLst>
+              <a:gd name="adj" fmla="val 8000"/>
+            </a:avLst>
+          </a:prstGeom>
+          <a:solidFill>
+            <a:srgbClr val="E8F3FF"/>
+          </a:solidFill>
+          <a:ln w="9525">
+            <a:solidFill>
+              <a:srgbClr val="B7DCFF"/>
+            </a:solidFill>
+            <a:prstDash val="solid"/>
+          </a:ln>
+        </p:spPr>
+        <p:txBody>
+          <a:bodyPr lIns="152400" tIns="152400" rIns="152400" bIns="152400" anchor="t">
+            <a:normAutofit fontScale="100000"/>
+          </a:bodyPr>
+          <a:lstStyle/>
+          <a:p>
+            <a:pPr algn="l">
+              <a:lnSpc>
+                <a:spcPct val="106000"/>
+              </a:lnSpc>
+              <a:buNone/>
+              <a:defRPr sz="1650" b="1">
+                <a:solidFill>
+                  <a:srgbClr val="0B5CAD"/>
+                </a:solidFill>
+                <a:latin typeface="Aptos Display"/>
+                <a:ea typeface="Aptos Display"/>
+                <a:cs typeface="Aptos Display"/>
+              </a:defRPr>
+            </a:pPr>
+            <a:r>
+              <a:rPr sz="1650" b="1">
+                <a:solidFill>
+                  <a:srgbClr val="0B5CAD"/>
+                </a:solidFill>
+                <a:latin typeface="Aptos Display"/>
+                <a:ea typeface="Aptos Display"/>
+                <a:cs typeface="Aptos Display"/>
+              </a:rPr>
+              <a:t>FROM</a:t>
+            </a:r>
+          </a:p>
+          <a:p>
+            <a:pPr algn="l">
+              <a:lnSpc>
+                <a:spcPct val="106000"/>
+              </a:lnSpc>
+              <a:buNone/>
+              <a:defRPr sz="1275" b="1">
+                <a:solidFill>
+                  <a:srgbClr val="111827"/>
+                </a:solidFill>
+                <a:latin typeface="Aptos"/>
+                <a:ea typeface="Aptos"/>
+                <a:cs typeface="Aptos"/>
+              </a:defRPr>
+            </a:pPr>
+            <a:r>
+              <a:rPr sz="1275" b="1">
+                <a:solidFill>
+                  <a:srgbClr val="111827"/>
+                </a:solidFill>
+                <a:latin typeface="Aptos"/>
+                <a:ea typeface="Aptos"/>
+                <a:cs typeface="Aptos"/>
+              </a:rPr>
+              <a:t>選 base image</a:t>
+            </a:r>
+          </a:p>
+          <a:p>
+            <a:pPr algn="l">
+              <a:lnSpc>
+                <a:spcPct val="106000"/>
+              </a:lnSpc>
+              <a:buNone/>
+              <a:defRPr sz="1050" b="0">
+                <a:solidFill>
+                  <a:srgbClr val="475569"/>
+                </a:solidFill>
+                <a:latin typeface="Aptos"/>
+                <a:ea typeface="Aptos"/>
+                <a:cs typeface="Aptos"/>
+              </a:defRPr>
+            </a:pPr>
+            <a:r>
+              <a:rPr sz="1050" b="0">
+                <a:solidFill>
+                  <a:srgbClr val="475569"/>
+                </a:solidFill>
+                <a:latin typeface="Aptos"/>
+                <a:ea typeface="Aptos"/>
+                <a:cs typeface="Aptos"/>
+              </a:rPr>
+              <a:t>例：python:3.11-slim</a:t>
+            </a:r>
+          </a:p>
+        </p:txBody>
+      </p:sp>
+      <p:sp>
+        <p:nvSpPr>
+          <p:cNvPr id="5" name=""/>
+          <p:cNvSpPr>
+            <a:spLocks noGrp="1"/>
+          </p:cNvSpPr>
+          <p:nvPr/>
+        </p:nvSpPr>
+        <p:spPr>
+          <a:xfrm>
+            <a:off x="3409950" y="1514475"/>
+            <a:ext cx="2571750" cy="971550"/>
+          </a:xfrm>
+          <a:prstGeom prst="roundRect">
+            <a:avLst>
+              <a:gd name="adj" fmla="val 8000"/>
+            </a:avLst>
+          </a:prstGeom>
+          <a:solidFill>
+            <a:srgbClr val="E8F3FF"/>
+          </a:solidFill>
+          <a:ln w="9525">
+            <a:solidFill>
+              <a:srgbClr val="B7DCFF"/>
+            </a:solidFill>
+            <a:prstDash val="solid"/>
+          </a:ln>
+        </p:spPr>
+        <p:txBody>
+          <a:bodyPr lIns="152400" tIns="152400" rIns="152400" bIns="152400" anchor="t">
+            <a:normAutofit fontScale="100000"/>
+          </a:bodyPr>
+          <a:lstStyle/>
+          <a:p>
+            <a:pPr algn="l">
+              <a:lnSpc>
+                <a:spcPct val="106000"/>
+              </a:lnSpc>
+              <a:buNone/>
+              <a:defRPr sz="1650" b="1">
+                <a:solidFill>
+                  <a:srgbClr val="0B5CAD"/>
+                </a:solidFill>
+                <a:latin typeface="Aptos Display"/>
+                <a:ea typeface="Aptos Display"/>
+                <a:cs typeface="Aptos Display"/>
+              </a:defRPr>
+            </a:pPr>
+            <a:r>
+              <a:rPr sz="1650" b="1">
+                <a:solidFill>
+                  <a:srgbClr val="0B5CAD"/>
+                </a:solidFill>
+                <a:latin typeface="Aptos Display"/>
+                <a:ea typeface="Aptos Display"/>
+                <a:cs typeface="Aptos Display"/>
+              </a:rPr>
+              <a:t>WORKDIR</a:t>
+            </a:r>
+          </a:p>
+          <a:p>
+            <a:pPr algn="l">
+              <a:lnSpc>
+                <a:spcPct val="106000"/>
+              </a:lnSpc>
+              <a:buNone/>
+              <a:defRPr sz="1275" b="1">
+                <a:solidFill>
+                  <a:srgbClr val="111827"/>
+                </a:solidFill>
+                <a:latin typeface="Aptos"/>
+                <a:ea typeface="Aptos"/>
+                <a:cs typeface="Aptos"/>
+              </a:defRPr>
+            </a:pPr>
+            <a:r>
+              <a:rPr sz="1275" b="1">
+                <a:solidFill>
+                  <a:srgbClr val="111827"/>
+                </a:solidFill>
+                <a:latin typeface="Aptos"/>
+                <a:ea typeface="Aptos"/>
+                <a:cs typeface="Aptos"/>
+              </a:rPr>
+              <a:t>設定工作目錄</a:t>
+            </a:r>
+          </a:p>
+          <a:p>
+            <a:pPr algn="l">
+              <a:lnSpc>
+                <a:spcPct val="106000"/>
+              </a:lnSpc>
+              <a:buNone/>
+              <a:defRPr sz="1050" b="0">
+                <a:solidFill>
+                  <a:srgbClr val="475569"/>
+                </a:solidFill>
+                <a:latin typeface="Aptos"/>
+                <a:ea typeface="Aptos"/>
+                <a:cs typeface="Aptos"/>
+              </a:defRPr>
+            </a:pPr>
+            <a:r>
+              <a:rPr sz="1050" b="0">
+                <a:solidFill>
+                  <a:srgbClr val="475569"/>
+                </a:solidFill>
+                <a:latin typeface="Aptos"/>
+                <a:ea typeface="Aptos"/>
+                <a:cs typeface="Aptos"/>
+              </a:rPr>
+              <a:t>後面的指令都在這裡跑</a:t>
+            </a:r>
+          </a:p>
+        </p:txBody>
+      </p:sp>
+      <p:sp>
+        <p:nvSpPr>
+          <p:cNvPr id="6" name=""/>
+          <p:cNvSpPr>
+            <a:spLocks noGrp="1"/>
+          </p:cNvSpPr>
+          <p:nvPr/>
+        </p:nvSpPr>
+        <p:spPr>
+          <a:xfrm>
+            <a:off x="6210300" y="1514475"/>
+            <a:ext cx="2571750" cy="971550"/>
+          </a:xfrm>
+          <a:prstGeom prst="roundRect">
+            <a:avLst>
+              <a:gd name="adj" fmla="val 8000"/>
+            </a:avLst>
+          </a:prstGeom>
+          <a:solidFill>
+            <a:srgbClr val="E8F3FF"/>
+          </a:solidFill>
+          <a:ln w="9525">
+            <a:solidFill>
+              <a:srgbClr val="B7DCFF"/>
+            </a:solidFill>
+            <a:prstDash val="solid"/>
+          </a:ln>
+        </p:spPr>
+        <p:txBody>
+          <a:bodyPr lIns="152400" tIns="152400" rIns="152400" bIns="152400" anchor="t">
+            <a:normAutofit fontScale="100000"/>
+          </a:bodyPr>
+          <a:lstStyle/>
+          <a:p>
+            <a:pPr algn="l">
+              <a:lnSpc>
+                <a:spcPct val="106000"/>
+              </a:lnSpc>
+              <a:buNone/>
+              <a:defRPr sz="1650" b="1">
+                <a:solidFill>
+                  <a:srgbClr val="0B5CAD"/>
+                </a:solidFill>
+                <a:latin typeface="Aptos Display"/>
+                <a:ea typeface="Aptos Display"/>
+                <a:cs typeface="Aptos Display"/>
+              </a:defRPr>
+            </a:pPr>
+            <a:r>
+              <a:rPr sz="1650" b="1">
+                <a:solidFill>
+                  <a:srgbClr val="0B5CAD"/>
+                </a:solidFill>
+                <a:latin typeface="Aptos Display"/>
+                <a:ea typeface="Aptos Display"/>
+                <a:cs typeface="Aptos Display"/>
+              </a:rPr>
+              <a:t>COPY</a:t>
+            </a:r>
+          </a:p>
+          <a:p>
+            <a:pPr algn="l">
+              <a:lnSpc>
+                <a:spcPct val="106000"/>
+              </a:lnSpc>
+              <a:buNone/>
+              <a:defRPr sz="1275" b="1">
+                <a:solidFill>
+                  <a:srgbClr val="111827"/>
+                </a:solidFill>
+                <a:latin typeface="Aptos"/>
+                <a:ea typeface="Aptos"/>
+                <a:cs typeface="Aptos"/>
+              </a:defRPr>
+            </a:pPr>
+            <a:r>
+              <a:rPr sz="1275" b="1">
+                <a:solidFill>
+                  <a:srgbClr val="111827"/>
+                </a:solidFill>
+                <a:latin typeface="Aptos"/>
+                <a:ea typeface="Aptos"/>
+                <a:cs typeface="Aptos"/>
+              </a:rPr>
+              <a:t>把檔案放進 image</a:t>
+            </a:r>
+          </a:p>
+          <a:p>
+            <a:pPr algn="l">
+              <a:lnSpc>
+                <a:spcPct val="106000"/>
+              </a:lnSpc>
+              <a:buNone/>
+              <a:defRPr sz="1050" b="0">
+                <a:solidFill>
+                  <a:srgbClr val="475569"/>
+                </a:solidFill>
+                <a:latin typeface="Aptos"/>
+                <a:ea typeface="Aptos"/>
+                <a:cs typeface="Aptos"/>
+              </a:defRPr>
+            </a:pPr>
+            <a:r>
+              <a:rPr sz="1050" b="0">
+                <a:solidFill>
+                  <a:srgbClr val="475569"/>
+                </a:solidFill>
+                <a:latin typeface="Aptos"/>
+                <a:ea typeface="Aptos"/>
+                <a:cs typeface="Aptos"/>
+              </a:rPr>
+              <a:t>初學先用 COPY，不急著用 ADD</a:t>
+            </a:r>
+          </a:p>
+        </p:txBody>
+      </p:sp>
+      <p:sp>
+        <p:nvSpPr>
+          <p:cNvPr id="7" name=""/>
+          <p:cNvSpPr>
+            <a:spLocks noGrp="1"/>
+          </p:cNvSpPr>
+          <p:nvPr/>
+        </p:nvSpPr>
+        <p:spPr>
+          <a:xfrm>
+            <a:off x="9010650" y="1514475"/>
+            <a:ext cx="2571750" cy="971550"/>
+          </a:xfrm>
+          <a:prstGeom prst="roundRect">
+            <a:avLst>
+              <a:gd name="adj" fmla="val 8000"/>
+            </a:avLst>
+          </a:prstGeom>
+          <a:solidFill>
+            <a:srgbClr val="E8F3FF"/>
+          </a:solidFill>
+          <a:ln w="9525">
+            <a:solidFill>
+              <a:srgbClr val="B7DCFF"/>
+            </a:solidFill>
+            <a:prstDash val="solid"/>
+          </a:ln>
+        </p:spPr>
+        <p:txBody>
+          <a:bodyPr lIns="152400" tIns="152400" rIns="152400" bIns="152400" anchor="t">
+            <a:normAutofit fontScale="100000"/>
+          </a:bodyPr>
+          <a:lstStyle/>
+          <a:p>
+            <a:pPr algn="l">
+              <a:lnSpc>
+                <a:spcPct val="106000"/>
+              </a:lnSpc>
+              <a:buNone/>
+              <a:defRPr sz="1650" b="1">
+                <a:solidFill>
+                  <a:srgbClr val="0B5CAD"/>
+                </a:solidFill>
+                <a:latin typeface="Aptos Display"/>
+                <a:ea typeface="Aptos Display"/>
+                <a:cs typeface="Aptos Display"/>
+              </a:defRPr>
+            </a:pPr>
+            <a:r>
+              <a:rPr sz="1650" b="1">
+                <a:solidFill>
+                  <a:srgbClr val="0B5CAD"/>
+                </a:solidFill>
+                <a:latin typeface="Aptos Display"/>
+                <a:ea typeface="Aptos Display"/>
+                <a:cs typeface="Aptos Display"/>
+              </a:rPr>
+              <a:t>RUN</a:t>
+            </a:r>
+          </a:p>
+          <a:p>
+            <a:pPr algn="l">
+              <a:lnSpc>
+                <a:spcPct val="106000"/>
+              </a:lnSpc>
+              <a:buNone/>
+              <a:defRPr sz="1275" b="1">
+                <a:solidFill>
+                  <a:srgbClr val="111827"/>
+                </a:solidFill>
+                <a:latin typeface="Aptos"/>
+                <a:ea typeface="Aptos"/>
+                <a:cs typeface="Aptos"/>
+              </a:defRPr>
+            </a:pPr>
+            <a:r>
+              <a:rPr sz="1275" b="1">
+                <a:solidFill>
+                  <a:srgbClr val="111827"/>
+                </a:solidFill>
+                <a:latin typeface="Aptos"/>
+                <a:ea typeface="Aptos"/>
+                <a:cs typeface="Aptos"/>
+              </a:rPr>
+              <a:t>build 時執行</a:t>
+            </a:r>
+          </a:p>
+          <a:p>
+            <a:pPr algn="l">
+              <a:lnSpc>
+                <a:spcPct val="106000"/>
+              </a:lnSpc>
+              <a:buNone/>
+              <a:defRPr sz="1050" b="0">
+                <a:solidFill>
+                  <a:srgbClr val="475569"/>
+                </a:solidFill>
+                <a:latin typeface="Aptos"/>
+                <a:ea typeface="Aptos"/>
+                <a:cs typeface="Aptos"/>
+              </a:defRPr>
+            </a:pPr>
+            <a:r>
+              <a:rPr sz="1050" b="0">
+                <a:solidFill>
+                  <a:srgbClr val="475569"/>
+                </a:solidFill>
+                <a:latin typeface="Aptos"/>
+                <a:ea typeface="Aptos"/>
+                <a:cs typeface="Aptos"/>
+              </a:rPr>
+              <a:t>安裝套件、建立資料夾</a:t>
+            </a:r>
+          </a:p>
+        </p:txBody>
+      </p:sp>
+      <p:sp>
+        <p:nvSpPr>
+          <p:cNvPr id="8" name=""/>
+          <p:cNvSpPr>
+            <a:spLocks noGrp="1"/>
+          </p:cNvSpPr>
+          <p:nvPr/>
+        </p:nvSpPr>
+        <p:spPr>
+          <a:xfrm>
+            <a:off x="609600" y="2733675"/>
+            <a:ext cx="2571750" cy="971550"/>
+          </a:xfrm>
+          <a:prstGeom prst="roundRect">
+            <a:avLst>
+              <a:gd name="adj" fmla="val 8000"/>
+            </a:avLst>
+          </a:prstGeom>
+          <a:solidFill>
+            <a:srgbClr val="FFFFFF"/>
+          </a:solidFill>
+          <a:ln w="9525">
+            <a:solidFill>
+              <a:srgbClr val="D9E2EC"/>
+            </a:solidFill>
+            <a:prstDash val="solid"/>
+          </a:ln>
+        </p:spPr>
+        <p:txBody>
+          <a:bodyPr lIns="152400" tIns="152400" rIns="152400" bIns="152400" anchor="t">
+            <a:normAutofit fontScale="100000"/>
+          </a:bodyPr>
+          <a:lstStyle/>
+          <a:p>
+            <a:pPr algn="l">
+              <a:lnSpc>
+                <a:spcPct val="106000"/>
+              </a:lnSpc>
+              <a:buNone/>
+              <a:defRPr sz="1650" b="1">
+                <a:solidFill>
+                  <a:srgbClr val="0B5CAD"/>
+                </a:solidFill>
+                <a:latin typeface="Aptos Display"/>
+                <a:ea typeface="Aptos Display"/>
+                <a:cs typeface="Aptos Display"/>
+              </a:defRPr>
+            </a:pPr>
+            <a:r>
+              <a:rPr sz="1650" b="1">
+                <a:solidFill>
+                  <a:srgbClr val="0B5CAD"/>
+                </a:solidFill>
+                <a:latin typeface="Aptos Display"/>
+                <a:ea typeface="Aptos Display"/>
+                <a:cs typeface="Aptos Display"/>
+              </a:rPr>
+              <a:t>CMD</a:t>
+            </a:r>
+          </a:p>
+          <a:p>
+            <a:pPr algn="l">
+              <a:lnSpc>
+                <a:spcPct val="106000"/>
+              </a:lnSpc>
+              <a:buNone/>
+              <a:defRPr sz="1275" b="1">
+                <a:solidFill>
+                  <a:srgbClr val="111827"/>
+                </a:solidFill>
+                <a:latin typeface="Aptos"/>
+                <a:ea typeface="Aptos"/>
+                <a:cs typeface="Aptos"/>
+              </a:defRPr>
+            </a:pPr>
+            <a:r>
+              <a:rPr sz="1275" b="1">
+                <a:solidFill>
+                  <a:srgbClr val="111827"/>
+                </a:solidFill>
+                <a:latin typeface="Aptos"/>
+                <a:ea typeface="Aptos"/>
+                <a:cs typeface="Aptos"/>
+              </a:rPr>
+              <a:t>container 啟動時執行</a:t>
+            </a:r>
+          </a:p>
+          <a:p>
+            <a:pPr algn="l">
+              <a:lnSpc>
+                <a:spcPct val="106000"/>
+              </a:lnSpc>
+              <a:buNone/>
+              <a:defRPr sz="1050" b="0">
+                <a:solidFill>
+                  <a:srgbClr val="475569"/>
+                </a:solidFill>
+                <a:latin typeface="Aptos"/>
+                <a:ea typeface="Aptos"/>
+                <a:cs typeface="Aptos"/>
+              </a:defRPr>
+            </a:pPr>
+            <a:r>
+              <a:rPr sz="1050" b="0">
+                <a:solidFill>
+                  <a:srgbClr val="475569"/>
+                </a:solidFill>
+                <a:latin typeface="Aptos"/>
+                <a:ea typeface="Aptos"/>
+                <a:cs typeface="Aptos"/>
+              </a:rPr>
+              <a:t>通常放啟動程式</a:t>
+            </a:r>
+          </a:p>
+        </p:txBody>
+      </p:sp>
+      <p:sp>
+        <p:nvSpPr>
+          <p:cNvPr id="9" name=""/>
+          <p:cNvSpPr>
+            <a:spLocks noGrp="1"/>
+          </p:cNvSpPr>
+          <p:nvPr/>
+        </p:nvSpPr>
+        <p:spPr>
+          <a:xfrm>
+            <a:off x="3409950" y="2733675"/>
+            <a:ext cx="2571750" cy="971550"/>
+          </a:xfrm>
+          <a:prstGeom prst="roundRect">
+            <a:avLst>
+              <a:gd name="adj" fmla="val 8000"/>
+            </a:avLst>
+          </a:prstGeom>
+          <a:solidFill>
+            <a:srgbClr val="FFFFFF"/>
+          </a:solidFill>
+          <a:ln w="9525">
+            <a:solidFill>
+              <a:srgbClr val="D9E2EC"/>
+            </a:solidFill>
+            <a:prstDash val="solid"/>
+          </a:ln>
+        </p:spPr>
+        <p:txBody>
+          <a:bodyPr lIns="152400" tIns="152400" rIns="152400" bIns="152400" anchor="t">
+            <a:normAutofit fontScale="100000"/>
+          </a:bodyPr>
+          <a:lstStyle/>
+          <a:p>
+            <a:pPr algn="l">
+              <a:lnSpc>
+                <a:spcPct val="106000"/>
+              </a:lnSpc>
+              <a:buNone/>
+              <a:defRPr sz="1650" b="1">
+                <a:solidFill>
+                  <a:srgbClr val="0B5CAD"/>
+                </a:solidFill>
+                <a:latin typeface="Aptos Display"/>
+                <a:ea typeface="Aptos Display"/>
+                <a:cs typeface="Aptos Display"/>
+              </a:defRPr>
+            </a:pPr>
+            <a:r>
+              <a:rPr sz="1650" b="1">
+                <a:solidFill>
+                  <a:srgbClr val="0B5CAD"/>
+                </a:solidFill>
+                <a:latin typeface="Aptos Display"/>
+                <a:ea typeface="Aptos Display"/>
+                <a:cs typeface="Aptos Display"/>
+              </a:rPr>
+              <a:t>EXPOSE</a:t>
+            </a:r>
+          </a:p>
+          <a:p>
+            <a:pPr algn="l">
+              <a:lnSpc>
+                <a:spcPct val="106000"/>
+              </a:lnSpc>
+              <a:buNone/>
+              <a:defRPr sz="1275" b="1">
+                <a:solidFill>
+                  <a:srgbClr val="111827"/>
+                </a:solidFill>
+                <a:latin typeface="Aptos"/>
+                <a:ea typeface="Aptos"/>
+                <a:cs typeface="Aptos"/>
+              </a:defRPr>
+            </a:pPr>
+            <a:r>
+              <a:rPr sz="1275" b="1">
+                <a:solidFill>
+                  <a:srgbClr val="111827"/>
+                </a:solidFill>
+                <a:latin typeface="Aptos"/>
+                <a:ea typeface="Aptos"/>
+                <a:cs typeface="Aptos"/>
+              </a:rPr>
+              <a:t>文件提示 port</a:t>
+            </a:r>
+          </a:p>
+          <a:p>
+            <a:pPr algn="l">
+              <a:lnSpc>
+                <a:spcPct val="106000"/>
+              </a:lnSpc>
+              <a:buNone/>
+              <a:defRPr sz="1050" b="0">
+                <a:solidFill>
+                  <a:srgbClr val="475569"/>
+                </a:solidFill>
+                <a:latin typeface="Aptos"/>
+                <a:ea typeface="Aptos"/>
+                <a:cs typeface="Aptos"/>
+              </a:defRPr>
+            </a:pPr>
+            <a:r>
+              <a:rPr sz="1050" b="0">
+                <a:solidFill>
+                  <a:srgbClr val="475569"/>
+                </a:solidFill>
+                <a:latin typeface="Aptos"/>
+                <a:ea typeface="Aptos"/>
+                <a:cs typeface="Aptos"/>
+              </a:rPr>
+              <a:t>不等於真的開 port</a:t>
+            </a:r>
+          </a:p>
+        </p:txBody>
+      </p:sp>
+      <p:sp>
+        <p:nvSpPr>
+          <p:cNvPr id="10" name=""/>
+          <p:cNvSpPr>
+            <a:spLocks noGrp="1"/>
+          </p:cNvSpPr>
+          <p:nvPr/>
+        </p:nvSpPr>
+        <p:spPr>
+          <a:xfrm>
+            <a:off x="6210300" y="2733675"/>
+            <a:ext cx="2571750" cy="971550"/>
+          </a:xfrm>
+          <a:prstGeom prst="roundRect">
+            <a:avLst>
+              <a:gd name="adj" fmla="val 8000"/>
+            </a:avLst>
+          </a:prstGeom>
+          <a:solidFill>
+            <a:srgbClr val="FFFFFF"/>
+          </a:solidFill>
+          <a:ln w="9525">
+            <a:solidFill>
+              <a:srgbClr val="D9E2EC"/>
+            </a:solidFill>
+            <a:prstDash val="solid"/>
+          </a:ln>
+        </p:spPr>
+        <p:txBody>
+          <a:bodyPr lIns="152400" tIns="152400" rIns="152400" bIns="152400" anchor="t">
+            <a:normAutofit fontScale="100000"/>
+          </a:bodyPr>
+          <a:lstStyle/>
+          <a:p>
+            <a:pPr algn="l">
+              <a:lnSpc>
+                <a:spcPct val="106000"/>
+              </a:lnSpc>
+              <a:buNone/>
+              <a:defRPr sz="1650" b="1">
+                <a:solidFill>
+                  <a:srgbClr val="0B5CAD"/>
+                </a:solidFill>
+                <a:latin typeface="Aptos Display"/>
+                <a:ea typeface="Aptos Display"/>
+                <a:cs typeface="Aptos Display"/>
+              </a:defRPr>
+            </a:pPr>
+            <a:r>
+              <a:rPr sz="1650" b="1">
+                <a:solidFill>
+                  <a:srgbClr val="0B5CAD"/>
+                </a:solidFill>
+                <a:latin typeface="Aptos Display"/>
+                <a:ea typeface="Aptos Display"/>
+                <a:cs typeface="Aptos Display"/>
+              </a:rPr>
+              <a:t>ENV</a:t>
+            </a:r>
+          </a:p>
+          <a:p>
+            <a:pPr algn="l">
+              <a:lnSpc>
+                <a:spcPct val="106000"/>
+              </a:lnSpc>
+              <a:buNone/>
+              <a:defRPr sz="1275" b="1">
+                <a:solidFill>
+                  <a:srgbClr val="111827"/>
+                </a:solidFill>
+                <a:latin typeface="Aptos"/>
+                <a:ea typeface="Aptos"/>
+                <a:cs typeface="Aptos"/>
+              </a:defRPr>
+            </a:pPr>
+            <a:r>
+              <a:rPr sz="1275" b="1">
+                <a:solidFill>
+                  <a:srgbClr val="111827"/>
+                </a:solidFill>
+                <a:latin typeface="Aptos"/>
+                <a:ea typeface="Aptos"/>
+                <a:cs typeface="Aptos"/>
+              </a:rPr>
+              <a:t>非機密設定</a:t>
+            </a:r>
+          </a:p>
+          <a:p>
+            <a:pPr algn="l">
+              <a:lnSpc>
+                <a:spcPct val="106000"/>
+              </a:lnSpc>
+              <a:buNone/>
+              <a:defRPr sz="1050" b="0">
+                <a:solidFill>
+                  <a:srgbClr val="475569"/>
+                </a:solidFill>
+                <a:latin typeface="Aptos"/>
+                <a:ea typeface="Aptos"/>
+                <a:cs typeface="Aptos"/>
+              </a:defRPr>
+            </a:pPr>
+            <a:r>
+              <a:rPr sz="1050" b="0">
+                <a:solidFill>
+                  <a:srgbClr val="475569"/>
+                </a:solidFill>
+                <a:latin typeface="Aptos"/>
+                <a:ea typeface="Aptos"/>
+                <a:cs typeface="Aptos"/>
+              </a:rPr>
+              <a:t>密碼、token 不放這裡</a:t>
+            </a:r>
+          </a:p>
+        </p:txBody>
+      </p:sp>
+      <p:sp>
+        <p:nvSpPr>
+          <p:cNvPr id="11" name=""/>
+          <p:cNvSpPr>
+            <a:spLocks noGrp="1"/>
+          </p:cNvSpPr>
+          <p:nvPr/>
+        </p:nvSpPr>
+        <p:spPr>
+          <a:xfrm>
+            <a:off x="9010650" y="2733675"/>
+            <a:ext cx="2571750" cy="971550"/>
+          </a:xfrm>
+          <a:prstGeom prst="roundRect">
+            <a:avLst>
+              <a:gd name="adj" fmla="val 8000"/>
+            </a:avLst>
+          </a:prstGeom>
+          <a:solidFill>
+            <a:srgbClr val="FFFFFF"/>
+          </a:solidFill>
+          <a:ln w="9525">
+            <a:solidFill>
+              <a:srgbClr val="D9E2EC"/>
+            </a:solidFill>
+            <a:prstDash val="solid"/>
+          </a:ln>
+        </p:spPr>
+        <p:txBody>
+          <a:bodyPr lIns="152400" tIns="152400" rIns="152400" bIns="152400" anchor="t">
+            <a:normAutofit fontScale="100000"/>
+          </a:bodyPr>
+          <a:lstStyle/>
+          <a:p>
+            <a:pPr algn="l">
+              <a:lnSpc>
+                <a:spcPct val="106000"/>
+              </a:lnSpc>
+              <a:buNone/>
+              <a:defRPr sz="1650" b="1">
+                <a:solidFill>
+                  <a:srgbClr val="0B5CAD"/>
+                </a:solidFill>
+                <a:latin typeface="Aptos Display"/>
+                <a:ea typeface="Aptos Display"/>
+                <a:cs typeface="Aptos Display"/>
+              </a:defRPr>
+            </a:pPr>
+            <a:r>
+              <a:rPr sz="1650" b="1">
+                <a:solidFill>
+                  <a:srgbClr val="0B5CAD"/>
+                </a:solidFill>
+                <a:latin typeface="Aptos Display"/>
+                <a:ea typeface="Aptos Display"/>
+                <a:cs typeface="Aptos Display"/>
+              </a:rPr>
+              <a:t>USER</a:t>
+            </a:r>
+          </a:p>
+          <a:p>
+            <a:pPr algn="l">
+              <a:lnSpc>
+                <a:spcPct val="106000"/>
+              </a:lnSpc>
+              <a:buNone/>
+              <a:defRPr sz="1275" b="1">
+                <a:solidFill>
+                  <a:srgbClr val="111827"/>
+                </a:solidFill>
+                <a:latin typeface="Aptos"/>
+                <a:ea typeface="Aptos"/>
+                <a:cs typeface="Aptos"/>
+              </a:defRPr>
+            </a:pPr>
+            <a:r>
+              <a:rPr sz="1275" b="1">
+                <a:solidFill>
+                  <a:srgbClr val="111827"/>
+                </a:solidFill>
+                <a:latin typeface="Aptos"/>
+                <a:ea typeface="Aptos"/>
+                <a:cs typeface="Aptos"/>
+              </a:rPr>
+              <a:t>不用 root 跑程式</a:t>
+            </a:r>
+          </a:p>
+          <a:p>
+            <a:pPr algn="l">
+              <a:lnSpc>
+                <a:spcPct val="106000"/>
+              </a:lnSpc>
+              <a:buNone/>
+              <a:defRPr sz="1050" b="0">
+                <a:solidFill>
+                  <a:srgbClr val="475569"/>
+                </a:solidFill>
+                <a:latin typeface="Aptos"/>
+                <a:ea typeface="Aptos"/>
+                <a:cs typeface="Aptos"/>
+              </a:defRPr>
+            </a:pPr>
+            <a:r>
+              <a:rPr sz="1050" b="0">
+                <a:solidFill>
+                  <a:srgbClr val="475569"/>
+                </a:solidFill>
+                <a:latin typeface="Aptos"/>
+                <a:ea typeface="Aptos"/>
+                <a:cs typeface="Aptos"/>
+              </a:rPr>
+              <a:t>production 會更常看到</a:t>
+            </a:r>
+          </a:p>
+        </p:txBody>
+      </p:sp>
+      <p:sp>
+        <p:nvSpPr>
+          <p:cNvPr id="12" name=""/>
+          <p:cNvSpPr>
+            <a:spLocks noGrp="1"/>
+          </p:cNvSpPr>
+          <p:nvPr/>
+        </p:nvSpPr>
+        <p:spPr>
+          <a:xfrm>
+            <a:off x="1143000" y="4210050"/>
+            <a:ext cx="9144000" cy="609600"/>
+          </a:xfrm>
+          <a:prstGeom prst="roundRect">
+            <a:avLst>
+              <a:gd name="adj" fmla="val 8000"/>
+            </a:avLst>
+          </a:prstGeom>
+          <a:solidFill>
+            <a:srgbClr val="EEF2F7"/>
+          </a:solidFill>
+          <a:ln w="9525">
+            <a:solidFill>
+              <a:srgbClr val="D9E2EC"/>
+            </a:solidFill>
+            <a:prstDash val="solid"/>
+          </a:ln>
+        </p:spPr>
+        <p:txBody>
+          <a:bodyPr lIns="152400" tIns="152400" rIns="152400" bIns="152400" anchor="t">
+            <a:normAutofit fontScale="100000"/>
+          </a:bodyPr>
+          <a:lstStyle/>
+          <a:p>
+            <a:pPr algn="ctr">
+              <a:lnSpc>
+                <a:spcPct val="106000"/>
+              </a:lnSpc>
+              <a:buNone/>
+              <a:defRPr sz="1500" b="1">
+                <a:solidFill>
+                  <a:srgbClr val="0B1220"/>
+                </a:solidFill>
+                <a:latin typeface="Aptos"/>
+                <a:ea typeface="Aptos"/>
+                <a:cs typeface="Aptos"/>
+              </a:defRPr>
+            </a:pPr>
+            <a:r>
+              <a:rPr sz="1500" b="1">
+                <a:solidFill>
+                  <a:srgbClr val="0B1220"/>
+                </a:solidFill>
+                <a:latin typeface="Aptos"/>
+                <a:ea typeface="Aptos"/>
+                <a:cs typeface="Aptos"/>
+              </a:rPr>
+              <a:t>這堂要會讀懂前七個；USER 和 ENV 先知道用途，細節之後遇到 production 再補。</a:t>
+            </a:r>
+          </a:p>
+        </p:txBody>
+      </p:sp>
+      <p:sp>
+        <p:nvSpPr>
+          <p:cNvPr id="40" name=""/>
+          <p:cNvSpPr>
+            <a:spLocks noGrp="1"/>
+          </p:cNvSpPr>
+          <p:nvPr/>
+        </p:nvSpPr>
+        <p:spPr>
+          <a:xfrm>
+            <a:off x="609600" y="6305550"/>
+            <a:ext cx="9906000" cy="13335"/>
+          </a:xfrm>
+          <a:prstGeom prst="rect">
+            <a:avLst/>
+          </a:prstGeom>
+          <a:solidFill>
+            <a:srgbClr val="D9E2EC"/>
+          </a:solidFill>
+          <a:ln w="0">
+            <a:noFill/>
+            <a:prstDash val="solid"/>
+          </a:ln>
+        </p:spPr>
+        <p:txBody>
+          <a:bodyPr lIns="0" tIns="0" rIns="0" bIns="0" anchor="t">
+            <a:normAutofit fontScale="100000"/>
+          </a:bodyPr>
+          <a:lstStyle/>
+        </p:txBody>
+      </p:sp>
+      <p:sp>
+        <p:nvSpPr>
+          <p:cNvPr id="41" name=""/>
+          <p:cNvSpPr>
+            <a:spLocks noGrp="1"/>
+          </p:cNvSpPr>
+          <p:nvPr/>
+        </p:nvSpPr>
+        <p:spPr>
+          <a:xfrm>
+            <a:off x="609600" y="6400800"/>
+            <a:ext cx="2762250" cy="171450"/>
+          </a:xfrm>
+          <a:prstGeom prst="rect">
+            <a:avLst/>
+          </a:prstGeom>
+          <a:noFill/>
+          <a:ln w="0">
+            <a:noFill/>
+            <a:prstDash val="solid"/>
+          </a:ln>
+        </p:spPr>
+        <p:txBody>
+          <a:bodyPr lIns="0" tIns="0" rIns="0" bIns="0" anchor="t">
+            <a:normAutofit fontScale="100000"/>
+          </a:bodyPr>
+          <a:lstStyle/>
+          <a:p>
+            <a:pPr algn="l">
+              <a:lnSpc>
+                <a:spcPct val="106000"/>
+              </a:lnSpc>
+              <a:buNone/>
+              <a:defRPr sz="825" b="0">
+                <a:solidFill>
+                  <a:srgbClr val="64748B"/>
+                </a:solidFill>
+                <a:latin typeface="Aptos"/>
+                <a:ea typeface="Aptos"/>
+                <a:cs typeface="Aptos"/>
+              </a:defRPr>
+            </a:pPr>
+            <a:r>
+              <a:rPr sz="825" b="0">
+                <a:solidFill>
+                  <a:srgbClr val="64748B"/>
+                </a:solidFill>
+                <a:latin typeface="Aptos"/>
+                <a:ea typeface="Aptos"/>
+                <a:cs typeface="Aptos"/>
+              </a:rPr>
+              <a:t>Docker 基礎教學 | 第 4 堂</a:t>
+            </a:r>
+          </a:p>
+        </p:txBody>
+      </p:sp>
+      <p:sp>
+        <p:nvSpPr>
+          <p:cNvPr id="42" name=""/>
+          <p:cNvSpPr>
+            <a:spLocks noGrp="1"/>
+          </p:cNvSpPr>
+          <p:nvPr/>
+        </p:nvSpPr>
+        <p:spPr>
+          <a:xfrm>
+            <a:off x="10858500" y="6381750"/>
+            <a:ext cx="723900" cy="190500"/>
+          </a:xfrm>
+          <a:prstGeom prst="rect">
+            <a:avLst/>
+          </a:prstGeom>
+          <a:noFill/>
+          <a:ln w="0">
+            <a:noFill/>
+            <a:prstDash val="solid"/>
+          </a:ln>
+        </p:spPr>
+        <p:txBody>
+          <a:bodyPr lIns="0" tIns="0" rIns="0" bIns="0" anchor="t">
+            <a:normAutofit fontScale="100000"/>
+          </a:bodyPr>
+          <a:lstStyle/>
+          <a:p>
+            <a:pPr algn="r">
+              <a:lnSpc>
+                <a:spcPct val="106000"/>
+              </a:lnSpc>
+              <a:buNone/>
+              <a:defRPr sz="900" b="1">
+                <a:solidFill>
+                  <a:srgbClr val="64748B"/>
+                </a:solidFill>
+                <a:latin typeface="Aptos"/>
+                <a:ea typeface="Aptos"/>
+                <a:cs typeface="Aptos"/>
+              </a:defRPr>
+            </a:pPr>
+            <a:r>
+              <a:rPr sz="900" b="1">
+                <a:solidFill>
+                  <a:srgbClr val="64748B"/>
+                </a:solidFill>
+                <a:latin typeface="Aptos"/>
+                <a:ea typeface="Aptos"/>
+                <a:cs typeface="Aptos"/>
+              </a:rPr>
+              <a:t>05A</a:t>
+            </a:r>
+          </a:p>
+        </p:txBody>
+      </p:sp>
+    </p:spTree>
+  </p:cSld>
+  <p:clrMapOvr>
+    <a:masterClrMapping/>
+  </p:clrMapOvr>
+</p:sld>
+</file>
+
+<file path=ppt/slides/slide49.xml><?xml version="1.0" encoding="utf-8"?>
+<p:sld xmlns:a="http://schemas.openxmlformats.org/drawingml/2006/main" xmlns:p="http://schemas.openxmlformats.org/presentationml/2006/main" xmlns:r="http://schemas.openxmlformats.org/officeDocument/2006/relationships">
+  <p:cSld name="RUN CMD EXPOSE 差異">
+    <p:bg>
+      <p:bgPr>
+        <a:solidFill>
+          <a:srgbClr val="F6F8FB"/>
+        </a:solidFill>
+      </p:bgPr>
+    </p:bg>
+    <p:spTree>
+      <p:nvGrpSpPr>
+        <p:cNvPr id="1" name=""/>
+        <p:cNvGrpSpPr/>
+        <p:nvPr/>
+      </p:nvGrpSpPr>
+      <p:grpSpPr>
+        <a:xfrm/>
+      </p:grpSpPr>
+      <p:sp>
+        <p:nvSpPr>
+          <p:cNvPr id="2" name=""/>
+          <p:cNvSpPr>
+            <a:spLocks noGrp="1"/>
+          </p:cNvSpPr>
+          <p:nvPr/>
+        </p:nvSpPr>
+        <p:spPr>
+          <a:xfrm>
+            <a:off x="609600" y="400050"/>
+            <a:ext cx="6191250" cy="228600"/>
+          </a:xfrm>
+          <a:prstGeom prst="rect">
+            <a:avLst/>
+          </a:prstGeom>
+          <a:noFill/>
+          <a:ln w="0">
+            <a:noFill/>
+            <a:prstDash val="solid"/>
+          </a:ln>
+        </p:spPr>
+        <p:txBody>
+          <a:bodyPr lIns="0" tIns="0" rIns="0" bIns="0" anchor="t">
+            <a:normAutofit fontScale="100000"/>
+          </a:bodyPr>
+          <a:lstStyle/>
+          <a:p>
+            <a:pPr algn="l">
+              <a:lnSpc>
+                <a:spcPct val="106000"/>
+              </a:lnSpc>
+              <a:buNone/>
+              <a:defRPr sz="900" b="1">
+                <a:solidFill>
+                  <a:srgbClr val="0B5CAD"/>
+                </a:solidFill>
+                <a:latin typeface="Aptos"/>
+                <a:ea typeface="Aptos"/>
+                <a:cs typeface="Aptos"/>
+              </a:defRPr>
+            </a:pPr>
+            <a:r>
+              <a:rPr sz="900" b="1">
+                <a:solidFill>
+                  <a:srgbClr val="0B5CAD"/>
+                </a:solidFill>
+                <a:latin typeface="Aptos"/>
+                <a:ea typeface="Aptos"/>
+                <a:cs typeface="Aptos"/>
+              </a:rPr>
+              <a:t>DOCKERFILE BEHAVIOR</a:t>
+            </a:r>
+          </a:p>
+        </p:txBody>
+      </p:sp>
+      <p:sp>
+        <p:nvSpPr>
+          <p:cNvPr id="3" name=""/>
+          <p:cNvSpPr>
+            <a:spLocks noGrp="1"/>
+          </p:cNvSpPr>
+          <p:nvPr/>
+        </p:nvSpPr>
+        <p:spPr>
+          <a:xfrm>
+            <a:off x="609600" y="742950"/>
+            <a:ext cx="9906000" cy="571500"/>
+          </a:xfrm>
+          <a:prstGeom prst="rect">
+            <a:avLst/>
+          </a:prstGeom>
+          <a:noFill/>
+          <a:ln w="0">
+            <a:noFill/>
+            <a:prstDash val="solid"/>
+          </a:ln>
+        </p:spPr>
+        <p:txBody>
+          <a:bodyPr lIns="0" tIns="0" rIns="0" bIns="0" anchor="t">
+            <a:normAutofit fontScale="100000"/>
+          </a:bodyPr>
+          <a:lstStyle/>
+          <a:p>
+            <a:pPr algn="l">
+              <a:lnSpc>
+                <a:spcPct val="106000"/>
+              </a:lnSpc>
+              <a:buNone/>
+              <a:defRPr sz="2850" b="1">
+                <a:solidFill>
+                  <a:srgbClr val="0B1220"/>
+                </a:solidFill>
+                <a:latin typeface="Aptos Display"/>
+                <a:ea typeface="Aptos Display"/>
+                <a:cs typeface="Aptos Display"/>
+              </a:defRPr>
+            </a:pPr>
+            <a:r>
+              <a:rPr sz="2850" b="1">
+                <a:solidFill>
+                  <a:srgbClr val="0B1220"/>
+                </a:solidFill>
+                <a:latin typeface="Aptos Display"/>
+                <a:ea typeface="Aptos Display"/>
+                <a:cs typeface="Aptos Display"/>
+              </a:rPr>
+              <a:t>RUN / CMD / EXPOSE 差異</a:t>
+            </a:r>
+          </a:p>
+        </p:txBody>
+      </p:sp>
+      <p:sp>
+        <p:nvSpPr>
+          <p:cNvPr id="4" name=""/>
+          <p:cNvSpPr>
+            <a:spLocks noGrp="1"/>
+          </p:cNvSpPr>
+          <p:nvPr/>
+        </p:nvSpPr>
+        <p:spPr>
+          <a:xfrm>
+            <a:off x="914400" y="1590675"/>
+            <a:ext cx="3276600" cy="2476500"/>
+          </a:xfrm>
+          <a:prstGeom prst="roundRect">
+            <a:avLst>
+              <a:gd name="adj" fmla="val 8000"/>
+            </a:avLst>
+          </a:prstGeom>
+          <a:solidFill>
+            <a:srgbClr val="E8F3FF"/>
+          </a:solidFill>
+          <a:ln w="9525">
+            <a:solidFill>
+              <a:srgbClr val="B7DCFF"/>
+            </a:solidFill>
+            <a:prstDash val="solid"/>
+          </a:ln>
+        </p:spPr>
+        <p:txBody>
+          <a:bodyPr lIns="190500" tIns="190500" rIns="190500" bIns="190500" anchor="t">
+            <a:normAutofit fontScale="100000"/>
+          </a:bodyPr>
+          <a:lstStyle/>
+          <a:p>
+            <a:pPr algn="ctr">
+              <a:lnSpc>
+                <a:spcPct val="106000"/>
+              </a:lnSpc>
+              <a:buNone/>
+              <a:defRPr sz="2100" b="1">
+                <a:solidFill>
+                  <a:srgbClr val="0B5CAD"/>
+                </a:solidFill>
+                <a:latin typeface="Aptos Display"/>
+                <a:ea typeface="Aptos Display"/>
+                <a:cs typeface="Aptos Display"/>
+              </a:defRPr>
+            </a:pPr>
+            <a:r>
+              <a:rPr sz="2100" b="1">
+                <a:solidFill>
+                  <a:srgbClr val="0B5CAD"/>
+                </a:solidFill>
+                <a:latin typeface="Aptos Display"/>
+                <a:ea typeface="Aptos Display"/>
+                <a:cs typeface="Aptos Display"/>
+              </a:rPr>
+              <a:t>RUN</a:t>
+            </a:r>
+          </a:p>
+          <a:p>
+            <a:pPr algn="ctr">
+              <a:lnSpc>
+                <a:spcPct val="106000"/>
+              </a:lnSpc>
+              <a:buNone/>
+              <a:defRPr sz="1500" b="1">
+                <a:solidFill>
+                  <a:srgbClr val="0B1220"/>
+                </a:solidFill>
+                <a:latin typeface="Aptos"/>
+                <a:ea typeface="Aptos"/>
+                <a:cs typeface="Aptos"/>
+              </a:defRPr>
+            </a:pPr>
+            <a:r>
+              <a:rPr sz="1500" b="1">
+                <a:solidFill>
+                  <a:srgbClr val="0B1220"/>
+                </a:solidFill>
+                <a:latin typeface="Aptos"/>
+                <a:ea typeface="Aptos"/>
+                <a:cs typeface="Aptos"/>
+              </a:rPr>
+              <a:t>build image 的時候跑</a:t>
+            </a:r>
+          </a:p>
+          <a:p>
+            <a:pPr algn="ctr">
+              <a:lnSpc>
+                <a:spcPct val="106000"/>
+              </a:lnSpc>
+              <a:buNone/>
+              <a:defRPr sz="1275" b="0">
+                <a:solidFill>
+                  <a:srgbClr val="334155"/>
+                </a:solidFill>
+                <a:latin typeface="Aptos"/>
+                <a:ea typeface="Aptos"/>
+                <a:cs typeface="Aptos"/>
+              </a:defRPr>
+            </a:pPr>
+            <a:r>
+              <a:rPr sz="1275" b="0">
+                <a:solidFill>
+                  <a:srgbClr val="334155"/>
+                </a:solidFill>
+                <a:latin typeface="Aptos"/>
+                <a:ea typeface="Aptos"/>
+                <a:cs typeface="Aptos"/>
+              </a:rPr>
+              <a:t>會產生新的 image layer</a:t>
+            </a:r>
+          </a:p>
+          <a:p>
+            <a:pPr algn="ctr">
+              <a:lnSpc>
+                <a:spcPct val="106000"/>
+              </a:lnSpc>
+              <a:buNone/>
+              <a:defRPr sz="1125" b="1">
+                <a:solidFill>
+                  <a:srgbClr val="0B1220"/>
+                </a:solidFill>
+                <a:latin typeface="Aptos"/>
+                <a:ea typeface="Aptos"/>
+                <a:cs typeface="Aptos"/>
+              </a:defRPr>
+            </a:pPr>
+            <a:r>
+              <a:rPr sz="1125" b="1">
+                <a:solidFill>
+                  <a:srgbClr val="0B1220"/>
+                </a:solidFill>
+                <a:latin typeface="Aptos"/>
+                <a:ea typeface="Aptos"/>
+                <a:cs typeface="Aptos"/>
+              </a:rPr>
+              <a:t>例：RUN pip install -r requirements.txt</a:t>
+            </a:r>
+          </a:p>
+        </p:txBody>
+      </p:sp>
+      <p:sp>
+        <p:nvSpPr>
+          <p:cNvPr id="5" name=""/>
+          <p:cNvSpPr>
+            <a:spLocks noGrp="1"/>
+          </p:cNvSpPr>
+          <p:nvPr/>
+        </p:nvSpPr>
+        <p:spPr>
+          <a:xfrm>
+            <a:off x="4495800" y="1590675"/>
+            <a:ext cx="3276600" cy="2476500"/>
+          </a:xfrm>
+          <a:prstGeom prst="roundRect">
+            <a:avLst>
+              <a:gd name="adj" fmla="val 8000"/>
+            </a:avLst>
+          </a:prstGeom>
+          <a:solidFill>
+            <a:srgbClr val="EAF7EF"/>
+          </a:solidFill>
+          <a:ln w="9525">
+            <a:solidFill>
+              <a:srgbClr val="B7E4C7"/>
+            </a:solidFill>
+            <a:prstDash val="solid"/>
+          </a:ln>
+        </p:spPr>
+        <p:txBody>
+          <a:bodyPr lIns="190500" tIns="190500" rIns="190500" bIns="190500" anchor="t">
+            <a:normAutofit fontScale="100000"/>
+          </a:bodyPr>
+          <a:lstStyle/>
+          <a:p>
+            <a:pPr algn="ctr">
+              <a:lnSpc>
+                <a:spcPct val="106000"/>
+              </a:lnSpc>
+              <a:buNone/>
+              <a:defRPr sz="2100" b="1">
+                <a:solidFill>
+                  <a:srgbClr val="087F5B"/>
+                </a:solidFill>
+                <a:latin typeface="Aptos Display"/>
+                <a:ea typeface="Aptos Display"/>
+                <a:cs typeface="Aptos Display"/>
+              </a:defRPr>
+            </a:pPr>
+            <a:r>
+              <a:rPr sz="2100" b="1">
+                <a:solidFill>
+                  <a:srgbClr val="087F5B"/>
+                </a:solidFill>
+                <a:latin typeface="Aptos Display"/>
+                <a:ea typeface="Aptos Display"/>
+                <a:cs typeface="Aptos Display"/>
+              </a:rPr>
+              <a:t>CMD</a:t>
+            </a:r>
+          </a:p>
+          <a:p>
+            <a:pPr algn="ctr">
+              <a:lnSpc>
+                <a:spcPct val="106000"/>
+              </a:lnSpc>
+              <a:buNone/>
+              <a:defRPr sz="1500" b="1">
+                <a:solidFill>
+                  <a:srgbClr val="0B1220"/>
+                </a:solidFill>
+                <a:latin typeface="Aptos"/>
+                <a:ea typeface="Aptos"/>
+                <a:cs typeface="Aptos"/>
+              </a:defRPr>
+            </a:pPr>
+            <a:r>
+              <a:rPr sz="1500" b="1">
+                <a:solidFill>
+                  <a:srgbClr val="0B1220"/>
+                </a:solidFill>
+                <a:latin typeface="Aptos"/>
+                <a:ea typeface="Aptos"/>
+                <a:cs typeface="Aptos"/>
+              </a:rPr>
+              <a:t>container 啟動時跑</a:t>
+            </a:r>
+          </a:p>
+          <a:p>
+            <a:pPr algn="ctr">
+              <a:lnSpc>
+                <a:spcPct val="106000"/>
+              </a:lnSpc>
+              <a:buNone/>
+              <a:defRPr sz="1275" b="0">
+                <a:solidFill>
+                  <a:srgbClr val="334155"/>
+                </a:solidFill>
+                <a:latin typeface="Aptos"/>
+                <a:ea typeface="Aptos"/>
+                <a:cs typeface="Aptos"/>
+              </a:defRPr>
+            </a:pPr>
+            <a:r>
+              <a:rPr sz="1275" b="0">
+                <a:solidFill>
+                  <a:srgbClr val="334155"/>
+                </a:solidFill>
+                <a:latin typeface="Aptos"/>
+                <a:ea typeface="Aptos"/>
+                <a:cs typeface="Aptos"/>
+              </a:rPr>
+              <a:t>可被 docker run 後面的 command 覆蓋</a:t>
+            </a:r>
+          </a:p>
+          <a:p>
+            <a:pPr algn="ctr">
+              <a:lnSpc>
+                <a:spcPct val="106000"/>
+              </a:lnSpc>
+              <a:buNone/>
+              <a:defRPr sz="1125" b="1">
+                <a:solidFill>
+                  <a:srgbClr val="0B1220"/>
+                </a:solidFill>
+                <a:latin typeface="Aptos"/>
+                <a:ea typeface="Aptos"/>
+                <a:cs typeface="Aptos"/>
+              </a:defRPr>
+            </a:pPr>
+            <a:r>
+              <a:rPr sz="1125" b="1">
+                <a:solidFill>
+                  <a:srgbClr val="0B1220"/>
+                </a:solidFill>
+                <a:latin typeface="Aptos"/>
+                <a:ea typeface="Aptos"/>
+                <a:cs typeface="Aptos"/>
+              </a:rPr>
+              <a:t>例：CMD ["python", "app.py"]</a:t>
+            </a:r>
+          </a:p>
+        </p:txBody>
+      </p:sp>
+      <p:sp>
+        <p:nvSpPr>
+          <p:cNvPr id="6" name=""/>
+          <p:cNvSpPr>
+            <a:spLocks noGrp="1"/>
+          </p:cNvSpPr>
+          <p:nvPr/>
+        </p:nvSpPr>
+        <p:spPr>
+          <a:xfrm>
+            <a:off x="8077200" y="1590675"/>
+            <a:ext cx="3276600" cy="2476500"/>
+          </a:xfrm>
+          <a:prstGeom prst="roundRect">
+            <a:avLst>
+              <a:gd name="adj" fmla="val 8000"/>
+            </a:avLst>
+          </a:prstGeom>
+          <a:solidFill>
+            <a:srgbClr val="FFF7E6"/>
+          </a:solidFill>
+          <a:ln w="9525">
+            <a:solidFill>
+              <a:srgbClr val="FFD999"/>
+            </a:solidFill>
+            <a:prstDash val="solid"/>
+          </a:ln>
+        </p:spPr>
+        <p:txBody>
+          <a:bodyPr lIns="190500" tIns="190500" rIns="190500" bIns="190500" anchor="t">
+            <a:normAutofit fontScale="100000"/>
+          </a:bodyPr>
+          <a:lstStyle/>
+          <a:p>
+            <a:pPr algn="ctr">
+              <a:lnSpc>
+                <a:spcPct val="106000"/>
+              </a:lnSpc>
+              <a:buNone/>
+              <a:defRPr sz="2100" b="1">
+                <a:solidFill>
+                  <a:srgbClr val="A16207"/>
+                </a:solidFill>
+                <a:latin typeface="Aptos Display"/>
+                <a:ea typeface="Aptos Display"/>
+                <a:cs typeface="Aptos Display"/>
+              </a:defRPr>
+            </a:pPr>
+            <a:r>
+              <a:rPr sz="2100" b="1">
+                <a:solidFill>
+                  <a:srgbClr val="A16207"/>
+                </a:solidFill>
+                <a:latin typeface="Aptos Display"/>
+                <a:ea typeface="Aptos Display"/>
+                <a:cs typeface="Aptos Display"/>
+              </a:rPr>
+              <a:t>EXPOSE</a:t>
+            </a:r>
+          </a:p>
+          <a:p>
+            <a:pPr algn="ctr">
+              <a:lnSpc>
+                <a:spcPct val="106000"/>
+              </a:lnSpc>
+              <a:buNone/>
+              <a:defRPr sz="1500" b="1">
+                <a:solidFill>
+                  <a:srgbClr val="0B1220"/>
+                </a:solidFill>
+                <a:latin typeface="Aptos"/>
+                <a:ea typeface="Aptos"/>
+                <a:cs typeface="Aptos"/>
+              </a:defRPr>
+            </a:pPr>
+            <a:r>
+              <a:rPr sz="1500" b="1">
+                <a:solidFill>
+                  <a:srgbClr val="0B1220"/>
+                </a:solidFill>
+                <a:latin typeface="Aptos"/>
+                <a:ea typeface="Aptos"/>
+                <a:cs typeface="Aptos"/>
+              </a:rPr>
+              <a:t>只是文件提示</a:t>
+            </a:r>
+          </a:p>
+          <a:p>
+            <a:pPr algn="ctr">
+              <a:lnSpc>
+                <a:spcPct val="106000"/>
+              </a:lnSpc>
+              <a:buNone/>
+              <a:defRPr sz="1275" b="0">
+                <a:solidFill>
+                  <a:srgbClr val="334155"/>
+                </a:solidFill>
+                <a:latin typeface="Aptos"/>
+                <a:ea typeface="Aptos"/>
+                <a:cs typeface="Aptos"/>
+              </a:defRPr>
+            </a:pPr>
+            <a:r>
+              <a:rPr sz="1275" b="0">
+                <a:solidFill>
+                  <a:srgbClr val="334155"/>
+                </a:solidFill>
+                <a:latin typeface="Aptos"/>
+                <a:ea typeface="Aptos"/>
+                <a:cs typeface="Aptos"/>
+              </a:rPr>
+              <a:t>不會自動對外開 port</a:t>
+            </a:r>
+          </a:p>
+          <a:p>
+            <a:pPr algn="ctr">
+              <a:lnSpc>
+                <a:spcPct val="106000"/>
+              </a:lnSpc>
+              <a:buNone/>
+              <a:defRPr sz="1125" b="1">
+                <a:solidFill>
+                  <a:srgbClr val="0B1220"/>
+                </a:solidFill>
+                <a:latin typeface="Aptos"/>
+                <a:ea typeface="Aptos"/>
+                <a:cs typeface="Aptos"/>
+              </a:defRPr>
+            </a:pPr>
+            <a:r>
+              <a:rPr sz="1125" b="1">
+                <a:solidFill>
+                  <a:srgbClr val="0B1220"/>
+                </a:solidFill>
+                <a:latin typeface="Aptos"/>
+                <a:ea typeface="Aptos"/>
+                <a:cs typeface="Aptos"/>
+              </a:rPr>
+              <a:t>仍要 -p 5000:5000 或 compose ports</a:t>
+            </a:r>
+          </a:p>
+        </p:txBody>
+      </p:sp>
+      <p:sp>
+        <p:nvSpPr>
+          <p:cNvPr id="8" name=""/>
+          <p:cNvSpPr>
+            <a:spLocks noGrp="1"/>
+          </p:cNvSpPr>
+          <p:nvPr/>
+        </p:nvSpPr>
+        <p:spPr>
+          <a:xfrm>
+            <a:off x="990600" y="4541525"/>
+            <a:ext cx="10210800" cy="628650"/>
+          </a:xfrm>
+          <a:prstGeom prst="roundRect">
+            <a:avLst>
+              <a:gd name="adj" fmla="val 8000"/>
+            </a:avLst>
+          </a:prstGeom>
+          <a:solidFill>
+            <a:srgbClr val="111827"/>
+          </a:solidFill>
+          <a:ln w="0">
+            <a:noFill/>
+            <a:prstDash val="solid"/>
+          </a:ln>
+        </p:spPr>
+        <p:txBody>
+          <a:bodyPr lIns="152400" tIns="152400" rIns="152400" bIns="152400" anchor="t">
+            <a:normAutofit fontScale="100000"/>
+          </a:bodyPr>
+          <a:lstStyle/>
+          <a:p>
+            <a:pPr algn="ctr">
+              <a:lnSpc>
+                <a:spcPct val="106000"/>
+              </a:lnSpc>
+              <a:buNone/>
+              <a:defRPr sz="1450" b="1">
+                <a:solidFill>
+                  <a:srgbClr val="FFFFFF"/>
+                </a:solidFill>
+                <a:latin typeface="Aptos"/>
+                <a:ea typeface="Aptos"/>
+                <a:cs typeface="Aptos"/>
+              </a:defRPr>
+            </a:pPr>
+            <a:r>
+              <a:rPr sz="1450" b="1">
+                <a:solidFill>
+                  <a:srgbClr val="FFFFFF"/>
+                </a:solidFill>
+                <a:latin typeface="Aptos"/>
+                <a:ea typeface="Aptos"/>
+                <a:cs typeface="Aptos"/>
+              </a:rPr>
+              <a:t>記法：RUN 做安裝，CMD 啟動程式，EXPOSE 留提醒。真的要開 port，要看 docker run -p 或 compose ports。</a:t>
+            </a:r>
+          </a:p>
+        </p:txBody>
+      </p:sp>
+      <p:sp>
+        <p:nvSpPr>
+          <p:cNvPr id="40" name=""/>
+          <p:cNvSpPr>
+            <a:spLocks noGrp="1"/>
+          </p:cNvSpPr>
+          <p:nvPr/>
+        </p:nvSpPr>
+        <p:spPr>
+          <a:xfrm>
+            <a:off x="609600" y="6305550"/>
+            <a:ext cx="9906000" cy="13335"/>
+          </a:xfrm>
+          <a:prstGeom prst="rect">
+            <a:avLst/>
+          </a:prstGeom>
+          <a:solidFill>
+            <a:srgbClr val="D9E2EC"/>
+          </a:solidFill>
+          <a:ln w="0">
+            <a:noFill/>
+            <a:prstDash val="solid"/>
+          </a:ln>
+        </p:spPr>
+        <p:txBody>
+          <a:bodyPr lIns="0" tIns="0" rIns="0" bIns="0" anchor="t">
+            <a:normAutofit fontScale="100000"/>
+          </a:bodyPr>
+          <a:lstStyle/>
+        </p:txBody>
+      </p:sp>
+      <p:sp>
+        <p:nvSpPr>
+          <p:cNvPr id="41" name=""/>
+          <p:cNvSpPr>
+            <a:spLocks noGrp="1"/>
+          </p:cNvSpPr>
+          <p:nvPr/>
+        </p:nvSpPr>
+        <p:spPr>
+          <a:xfrm>
+            <a:off x="609600" y="6400800"/>
+            <a:ext cx="2762250" cy="171450"/>
+          </a:xfrm>
+          <a:prstGeom prst="rect">
+            <a:avLst/>
+          </a:prstGeom>
+          <a:noFill/>
+          <a:ln w="0">
+            <a:noFill/>
+            <a:prstDash val="solid"/>
+          </a:ln>
+        </p:spPr>
+        <p:txBody>
+          <a:bodyPr lIns="0" tIns="0" rIns="0" bIns="0" anchor="t">
+            <a:normAutofit fontScale="100000"/>
+          </a:bodyPr>
+          <a:lstStyle/>
+          <a:p>
+            <a:pPr algn="l">
+              <a:lnSpc>
+                <a:spcPct val="106000"/>
+              </a:lnSpc>
+              <a:buNone/>
+              <a:defRPr sz="825" b="0">
+                <a:solidFill>
+                  <a:srgbClr val="64748B"/>
+                </a:solidFill>
+                <a:latin typeface="Aptos"/>
+                <a:ea typeface="Aptos"/>
+                <a:cs typeface="Aptos"/>
+              </a:defRPr>
+            </a:pPr>
+            <a:r>
+              <a:rPr sz="825" b="0">
+                <a:solidFill>
+                  <a:srgbClr val="64748B"/>
+                </a:solidFill>
+                <a:latin typeface="Aptos"/>
+                <a:ea typeface="Aptos"/>
+                <a:cs typeface="Aptos"/>
+              </a:rPr>
+              <a:t>Docker 基礎教學 | 第 4 堂</a:t>
+            </a:r>
+          </a:p>
+        </p:txBody>
+      </p:sp>
+      <p:sp>
+        <p:nvSpPr>
+          <p:cNvPr id="42" name=""/>
+          <p:cNvSpPr>
+            <a:spLocks noGrp="1"/>
+          </p:cNvSpPr>
+          <p:nvPr/>
+        </p:nvSpPr>
+        <p:spPr>
+          <a:xfrm>
+            <a:off x="10858500" y="6381750"/>
+            <a:ext cx="723900" cy="190500"/>
+          </a:xfrm>
+          <a:prstGeom prst="rect">
+            <a:avLst/>
+          </a:prstGeom>
+          <a:noFill/>
+          <a:ln w="0">
+            <a:noFill/>
+            <a:prstDash val="solid"/>
+          </a:ln>
+        </p:spPr>
+        <p:txBody>
+          <a:bodyPr lIns="0" tIns="0" rIns="0" bIns="0" anchor="t">
+            <a:normAutofit fontScale="100000"/>
+          </a:bodyPr>
+          <a:lstStyle/>
+          <a:p>
+            <a:pPr algn="r">
+              <a:lnSpc>
+                <a:spcPct val="106000"/>
+              </a:lnSpc>
+              <a:buNone/>
+              <a:defRPr sz="900" b="1">
+                <a:solidFill>
+                  <a:srgbClr val="64748B"/>
+                </a:solidFill>
+                <a:latin typeface="Aptos"/>
+                <a:ea typeface="Aptos"/>
+                <a:cs typeface="Aptos"/>
+              </a:defRPr>
+            </a:pPr>
+            <a:r>
+              <a:rPr sz="900" b="1">
+                <a:solidFill>
+                  <a:srgbClr val="64748B"/>
+                </a:solidFill>
+                <a:latin typeface="Aptos"/>
+                <a:ea typeface="Aptos"/>
+                <a:cs typeface="Aptos"/>
+              </a:rPr>
+              <a:t>05B</a:t>
+            </a:r>
+          </a:p>
+        </p:txBody>
+      </p:sp>
+    </p:spTree>
+  </p:cSld>
+  <p:clrMapOvr>
+    <a:masterClrMapping/>
+  </p:clrMapOvr>
+</p:sld>
+</file>
+
 <file path=ppt/slides/slide5.xml><?xml version="1.0" encoding="utf-8"?>
 <p:sld xmlns:a="http://schemas.openxmlformats.org/drawingml/2006/main" xmlns:ns2="http://schemas.microsoft.com/office/drawing/2014/main" xmlns:ns3="http://schemas.microsoft.com/office/powerpoint/2010/main" xmlns:p="http://schemas.openxmlformats.org/presentationml/2006/main">
   <p:cSld>

</xml_diff>